<commit_message>
App: filesystem-driven experiment ledger, tighter-threshold accuracy display
- app/app.py: Experiment Results page now reads every experiments/*/REPORT.md
  live from disk and classifies each by its title/status line, replacing the
  hand-curated subset - counts (42 total, 5 integrated) can't drift out of
  sync with what's actually on disk. Executive Summary adds accuracy@1/2/4px
  alongside @5px (identical at 2/4/5px - the bimodality finding as a
  measurement) and drops the hardcoded pre-integration delta constant.
- README.md: environment table for the 3.72s/pair figure, experiment-count
  note (42 directories, 5 reached production).
- Kaccha Mango_PS02.pptx: slide update.

No pipeline/, generator/ or evaluation/ changes.
</commit_message>
<xml_diff>
--- a/Kaccha Mango_PS02.pptx
+++ b/Kaccha Mango_PS02.pptx
@@ -3245,45 +3245,6 @@
       </p:pic>
       <p:sp>
         <p:nvSpPr>
-          <p:cNvPr id="29" name="Text 23"/>
-          <p:cNvSpPr txBox="1"/>
-          <p:nvPr/>
-        </p:nvSpPr>
-        <p:spPr>
-          <a:xfrm>
-            <a:off x="780898" y="4120286"/>
-            <a:ext cx="5574182" cy="200254"/>
-          </a:xfrm>
-          <a:prstGeom prst="rect">
-            <a:avLst/>
-          </a:prstGeom>
-          <a:noFill/>
-          <a:ln/>
-        </p:spPr>
-        <p:txBody>
-          <a:bodyPr wrap="square" lIns="0" tIns="0" rIns="0" bIns="0" rtlCol="0" anchor="ctr"/>
-          <a:lstStyle/>
-          <a:p>
-            <a:pPr marL="0" indent="0" algn="l">
-              <a:buNone/>
-            </a:pPr>
-            <a:r>
-              <a:rPr lang="en-US" sz="1000" b="1" i="1" dirty="0">
-                <a:solidFill>
-                  <a:srgbClr val="AAAAAA"/>
-                </a:solidFill>
-                <a:latin typeface="Poppins" pitchFamily="34" charset="0"/>
-                <a:ea typeface="Poppins" pitchFamily="34" charset="-122"/>
-                <a:cs typeface="Poppins" pitchFamily="34" charset="-120"/>
-              </a:rPr>
-              <a:t>A team can have up to 4 members including the team leader. Add rows if necessary.</a:t>
-            </a:r>
-            <a:endParaRPr lang="en-US" sz="1000" b="1" dirty="0"/>
-          </a:p>
-        </p:txBody>
-      </p:sp>
-      <p:sp>
-        <p:nvSpPr>
           <p:cNvPr id="30" name="Shape 24"/>
           <p:cNvSpPr/>
           <p:nvPr/>
@@ -4258,7 +4219,7 @@
         <p:spPr>
           <a:xfrm>
             <a:off x="8492033" y="2270455"/>
-            <a:ext cx="975665" cy="200254"/>
+            <a:ext cx="975665" cy="201168"/>
           </a:xfrm>
           <a:prstGeom prst="rect">
             <a:avLst/>
@@ -4358,7 +4319,7 @@
         <p:spPr>
           <a:xfrm>
             <a:off x="8492033" y="2725826"/>
-            <a:ext cx="975665" cy="200254"/>
+            <a:ext cx="975665" cy="201168"/>
           </a:xfrm>
           <a:prstGeom prst="rect">
             <a:avLst/>
@@ -4444,7 +4405,7 @@
         <p:spPr>
           <a:xfrm>
             <a:off x="8492033" y="3181198"/>
-            <a:ext cx="975665" cy="200254"/>
+            <a:ext cx="975665" cy="201168"/>
           </a:xfrm>
           <a:prstGeom prst="rect">
             <a:avLst/>
@@ -4519,7 +4480,7 @@
         <p:spPr>
           <a:xfrm>
             <a:off x="8492033" y="3636569"/>
-            <a:ext cx="975665" cy="200254"/>
+            <a:ext cx="975665" cy="201168"/>
           </a:xfrm>
           <a:prstGeom prst="rect">
             <a:avLst/>
@@ -5229,7 +5190,7 @@
         </p:nvSpPr>
         <p:spPr>
           <a:xfrm>
-            <a:off x="1200607" y="4283050"/>
+            <a:off x="1200607" y="3931463"/>
             <a:ext cx="8968435" cy="1920240"/>
           </a:xfrm>
           <a:prstGeom prst="rect">
@@ -5252,7 +5213,7 @@
               <a:buNone/>
             </a:pPr>
             <a:r>
-              <a:rPr sz="1200">
+              <a:rPr sz="1200" dirty="0">
                 <a:solidFill>
                   <a:srgbClr val="FFFFFF"/>
                 </a:solidFill>
@@ -5272,13 +5233,31 @@
               </a:spcAft>
             </a:pPr>
             <a:r>
-              <a:rPr sz="1200">
+              <a:rPr sz="1200" dirty="0">
                 <a:solidFill>
                   <a:srgbClr val="FFFFFF"/>
                 </a:solidFill>
                 <a:latin typeface="Poppins"/>
               </a:rPr>
-              <a:t>Real DRAM structure is highly repetitive: a wrong periodic repeat can score almost identically to the true site. DriftSense recovers the target center (x, y) automatically, with a confidence/ambiguity score alongside it.</a:t>
+              <a:t>Real DRAM structure is highly repetitive: a wrong periodic repeat can score almost identically to the true site. </a:t>
+            </a:r>
+            <a:r>
+              <a:rPr sz="1200" dirty="0" err="1">
+                <a:solidFill>
+                  <a:srgbClr val="FFFFFF"/>
+                </a:solidFill>
+                <a:latin typeface="Poppins"/>
+              </a:rPr>
+              <a:t>DriftSense</a:t>
+            </a:r>
+            <a:r>
+              <a:rPr sz="1200" dirty="0">
+                <a:solidFill>
+                  <a:srgbClr val="FFFFFF"/>
+                </a:solidFill>
+                <a:latin typeface="Poppins"/>
+              </a:rPr>
+              <a:t> recovers the target center (x, y) automatically, with a confidence/ambiguity score alongside it.</a:t>
             </a:r>
           </a:p>
         </p:txBody>
@@ -5611,37 +5590,7 @@
                 <a:ea typeface="Poppins" pitchFamily="34" charset="-122"/>
                 <a:cs typeface="Poppins" pitchFamily="34" charset="-120"/>
               </a:rPr>
-              <a:t>Idea Description - </a:t>
-            </a:r>
-            <a:r>
-              <a:rPr lang="en-US" sz="2400" b="1" dirty="0">
-                <a:solidFill>
-                  <a:schemeClr val="tx2"/>
-                </a:solidFill>
-                <a:latin typeface="Poppins" panose="00000500000000000000" pitchFamily="2" charset="0"/>
-                <a:cs typeface="Poppins" panose="00000500000000000000" pitchFamily="2" charset="0"/>
-              </a:rPr>
-              <a:t>Describe your Idea/Solution</a:t>
-            </a:r>
-            <a:r>
-              <a:rPr lang="en-US" sz="2400" b="1" u="sng" dirty="0">
-                <a:solidFill>
-                  <a:schemeClr val="tx2"/>
-                </a:solidFill>
-                <a:latin typeface="Poppins" panose="00000500000000000000" pitchFamily="2" charset="0"/>
-                <a:cs typeface="Poppins" panose="00000500000000000000" pitchFamily="2" charset="0"/>
-              </a:rPr>
-              <a:t>/</a:t>
-            </a:r>
-            <a:r>
-              <a:rPr lang="en-US" sz="2400" b="1" dirty="0">
-                <a:solidFill>
-                  <a:schemeClr val="tx2"/>
-                </a:solidFill>
-                <a:latin typeface="Poppins" panose="00000500000000000000" pitchFamily="2" charset="0"/>
-                <a:cs typeface="Poppins" panose="00000500000000000000" pitchFamily="2" charset="0"/>
-              </a:rPr>
-              <a:t>Prototype</a:t>
+              <a:t>Idea Description</a:t>
             </a:r>
             <a:endParaRPr lang="en-US" sz="2600" dirty="0">
               <a:latin typeface="Poppins" panose="00000500000000000000" pitchFamily="2" charset="0"/>
@@ -5902,7 +5851,7 @@
                 <a:ea typeface="Poppins" pitchFamily="34" charset="-122"/>
                 <a:cs typeface="Poppins" pitchFamily="34" charset="-120"/>
               </a:rPr>
-              <a:t>Provide a brief summary of your idea, including the key concept and approach. Provide a brief overview of your solution and how it addresses the problem statement.</a:t>
+              <a:t>A classical, fully-reproducible localizer: search the scale x rotation space explicitly, score by normalised cross-correlation, and say so when the answer is not decisive.</a:t>
             </a:r>
             <a:endParaRPr lang="en-US" sz="1600" dirty="0"/>
           </a:p>
@@ -6472,37 +6421,7 @@
                 <a:ea typeface="Poppins" pitchFamily="34" charset="-122"/>
                 <a:cs typeface="Poppins" pitchFamily="34" charset="-120"/>
               </a:rPr>
-              <a:t>Proposed Solution -</a:t>
-            </a:r>
-            <a:r>
-              <a:rPr lang="en-US" sz="2400" b="1" dirty="0">
-                <a:solidFill>
-                  <a:schemeClr val="tx2"/>
-                </a:solidFill>
-                <a:latin typeface="Poppins" panose="00000500000000000000" pitchFamily="2" charset="0"/>
-                <a:cs typeface="Poppins" panose="00000500000000000000" pitchFamily="2" charset="0"/>
-              </a:rPr>
-              <a:t> Describe your Idea/Solution</a:t>
-            </a:r>
-            <a:r>
-              <a:rPr lang="en-US" sz="2400" b="1" u="sng" dirty="0">
-                <a:solidFill>
-                  <a:schemeClr val="tx2"/>
-                </a:solidFill>
-                <a:latin typeface="Poppins" panose="00000500000000000000" pitchFamily="2" charset="0"/>
-                <a:cs typeface="Poppins" panose="00000500000000000000" pitchFamily="2" charset="0"/>
-              </a:rPr>
-              <a:t>/</a:t>
-            </a:r>
-            <a:r>
-              <a:rPr lang="en-US" sz="2400" b="1" dirty="0">
-                <a:solidFill>
-                  <a:schemeClr val="tx2"/>
-                </a:solidFill>
-                <a:latin typeface="Poppins" panose="00000500000000000000" pitchFamily="2" charset="0"/>
-                <a:cs typeface="Poppins" panose="00000500000000000000" pitchFamily="2" charset="0"/>
-              </a:rPr>
-              <a:t>Prototype</a:t>
+              <a:t>Proposed Solution</a:t>
             </a:r>
             <a:endParaRPr lang="en-US" sz="2600" dirty="0"/>
           </a:p>
@@ -6760,7 +6679,7 @@
                 <a:ea typeface="Poppins" pitchFamily="34" charset="-122"/>
                 <a:cs typeface="Poppins" pitchFamily="34" charset="-120"/>
               </a:rPr>
-              <a:t>Describe your idea in detail. Include the methodology, technologies involved, and how it addresses the chosen problem statement.</a:t>
+              <a:t>Two connected parts, both runnable from the repository root: a physically-grounded synthetic DRAM generator, and a deterministic classical localization pipeline.</a:t>
             </a:r>
             <a:endParaRPr lang="en-US" sz="1800" dirty="0"/>
           </a:p>
@@ -6849,7 +6768,7 @@
         </p:nvSpPr>
         <p:spPr>
           <a:xfrm>
-            <a:off x="1200607" y="4648810"/>
+            <a:off x="1200607" y="4528286"/>
             <a:ext cx="8996782" cy="1691640"/>
           </a:xfrm>
           <a:prstGeom prst="rect">
@@ -6872,13 +6791,31 @@
               <a:buNone/>
             </a:pPr>
             <a:r>
-              <a:rPr sz="1050">
+              <a:rPr sz="1050" dirty="0">
                 <a:solidFill>
                   <a:srgbClr val="FFFFFF"/>
                 </a:solidFill>
                 <a:latin typeface="Poppins"/>
               </a:rPr>
-              <a:t>Pipeline: Reference → candidate generation (ZNCC over a 9x9 grid of scale x rotation hypotheses, ±8% scale / ±5°) → dedup → ranking (highest-score match) → sub-pixel refinement → (x, y) + confidence/ambiguity score.</a:t>
+              <a:t>Pipeline: Reference → candidate generation (ZNCC over 99 scale × rotation hypotheses — 11 scales spanning the literal 9:1–11:1 range × 9 rotations across ±5°, built with both a sharp and a PSF-matched template) → </a:t>
+            </a:r>
+            <a:r>
+              <a:rPr sz="1050" dirty="0" err="1">
+                <a:solidFill>
+                  <a:srgbClr val="FFFFFF"/>
+                </a:solidFill>
+                <a:latin typeface="Poppins"/>
+              </a:rPr>
+              <a:t>dedup</a:t>
+            </a:r>
+            <a:r>
+              <a:rPr sz="1050" dirty="0">
+                <a:solidFill>
+                  <a:srgbClr val="FFFFFF"/>
+                </a:solidFill>
+                <a:latin typeface="Poppins"/>
+              </a:rPr>
+              <a:t> → ranking → sub-pixel refinement → (x, y) with a confidence and ambiguity score.</a:t>
             </a:r>
             <a:endParaRPr lang="en-US" sz="1300" dirty="0"/>
           </a:p>
@@ -6892,7 +6829,7 @@
               </a:spcAft>
             </a:pPr>
             <a:r>
-              <a:rPr sz="1050">
+              <a:rPr sz="1050" dirty="0">
                 <a:solidFill>
                   <a:srgbClr val="FFFFFF"/>
                 </a:solidFill>
@@ -6911,13 +6848,13 @@
               </a:spcAft>
             </a:pPr>
             <a:r>
-              <a:rPr sz="1050">
+              <a:rPr sz="1050" dirty="0">
                 <a:solidFill>
                   <a:srgbClr val="FFFFFF"/>
                 </a:solidFill>
                 <a:latin typeface="Poppins"/>
               </a:rPr>
-              <a:t>The hypothesis grid was widened from 5x5 to 9x9 (same span, finer step) after validation showed this recovers rotation/scale-drift failures without affecting unrelated cases.</a:t>
+              <a:t>The grid was densified (5→9 steps) and then widened to the literal 9:1–11:1 span; a PSF-matched dual-arm template and a recalibrated ambiguity threshold followed. Each shipped as a documented gate exception, logged with the criteria it did not clear.</a:t>
             </a:r>
           </a:p>
         </p:txBody>
@@ -7511,7 +7448,7 @@
                 <a:ea typeface="Poppins" pitchFamily="34" charset="-122"/>
                 <a:cs typeface="Poppins" pitchFamily="34" charset="-120"/>
               </a:rPr>
-              <a:t>Highlight what makes your idea unique or innovative compared to existing solutions.</a:t>
+              <a:t>What is unusual here is not the matcher - it is the evidence standard every change had to clear before it was allowed into production.</a:t>
             </a:r>
             <a:endParaRPr lang="en-US" sz="1800" dirty="0"/>
           </a:p>
@@ -7600,8 +7537,8 @@
         </p:nvSpPr>
         <p:spPr>
           <a:xfrm>
-            <a:off x="1200607" y="4349801"/>
-            <a:ext cx="4429354" cy="1188720"/>
+            <a:off x="1200607" y="4389120"/>
+            <a:ext cx="4429354" cy="1417320"/>
           </a:xfrm>
           <a:prstGeom prst="rect">
             <a:avLst/>
@@ -7610,7 +7547,7 @@
           <a:ln/>
         </p:spPr>
         <p:txBody>
-          <a:bodyPr wrap="square" lIns="0" tIns="0" rIns="0" bIns="0" rtlCol="0" anchor="ctr"/>
+          <a:bodyPr wrap="square" lIns="0" tIns="0" rIns="0" bIns="0" rtlCol="0" anchor="t"/>
           <a:lstStyle/>
           <a:p>
             <a:pPr marL="0" indent="0" algn="l">
@@ -7623,7 +7560,7 @@
               <a:buNone/>
             </a:pPr>
             <a:r>
-              <a:rPr sz="1100">
+              <a:rPr sz="1100" dirty="0">
                 <a:solidFill>
                   <a:srgbClr val="FFFFFF"/>
                 </a:solidFill>
@@ -7718,8 +7655,8 @@
         </p:nvSpPr>
         <p:spPr>
           <a:xfrm>
-            <a:off x="6448349" y="4349801"/>
-            <a:ext cx="4239158" cy="1188720"/>
+            <a:off x="6448349" y="4352544"/>
+            <a:ext cx="4239158" cy="1417320"/>
           </a:xfrm>
           <a:prstGeom prst="rect">
             <a:avLst/>
@@ -7728,7 +7665,7 @@
           <a:ln/>
         </p:spPr>
         <p:txBody>
-          <a:bodyPr wrap="square" lIns="0" tIns="0" rIns="0" bIns="0" rtlCol="0" anchor="ctr"/>
+          <a:bodyPr wrap="square" lIns="0" tIns="0" rIns="0" bIns="0" rtlCol="0" anchor="t"/>
           <a:lstStyle/>
           <a:p>
             <a:pPr marL="0" indent="0" algn="l">
@@ -7741,13 +7678,13 @@
               <a:buNone/>
             </a:pPr>
             <a:r>
-              <a:rPr sz="1100">
+              <a:rPr sz="1100" dirty="0">
                 <a:solidFill>
                   <a:srgbClr val="FFFFFF"/>
                 </a:solidFill>
                 <a:latin typeface="Poppins"/>
               </a:rPr>
-              <a:t>Every candidate improvement (finer hypothesis grid, learned re-ranker, periodicity scoring, wider candidate pool) is tested against a mandatory integration gate on held-out and external data before being trusted — most were honestly rejected; one validated change shipped.</a:t>
+              <a:t>Every candidate change — 42 isolated experiments including a learned re-ranker, periodicity-aware re-ranking and alternative correlation scores — must clear a mandatory 7-criterion integration gate on held-out and external data. Most were rejected and kept with their evidence; four shipped as documented exceptions.</a:t>
             </a:r>
             <a:endParaRPr lang="en-US" sz="1200" dirty="0"/>
           </a:p>
@@ -8342,33 +8279,7 @@
                 <a:ea typeface="Poppins" pitchFamily="34" charset="-122"/>
                 <a:cs typeface="Poppins" pitchFamily="34" charset="-120"/>
               </a:rPr>
-              <a:t>Explain how your solution will make an impact, such as improving </a:t>
-            </a:r>
-            <a:r>
-              <a:rPr lang="en-US" dirty="0">
-                <a:solidFill>
-                  <a:srgbClr val="AEFF82">
-                    <a:alpha val="80000"/>
-                  </a:srgbClr>
-                </a:solidFill>
-                <a:latin typeface="Poppins" pitchFamily="34" charset="0"/>
-                <a:ea typeface="Poppins" pitchFamily="34" charset="-122"/>
-                <a:cs typeface="Poppins" pitchFamily="34" charset="-120"/>
-              </a:rPr>
-              <a:t>performance</a:t>
-            </a:r>
-            <a:r>
-              <a:rPr lang="en-US" sz="1800" dirty="0">
-                <a:solidFill>
-                  <a:srgbClr val="AEFF82">
-                    <a:alpha val="80000"/>
-                  </a:srgbClr>
-                </a:solidFill>
-                <a:latin typeface="Poppins" pitchFamily="34" charset="0"/>
-                <a:ea typeface="Poppins" pitchFamily="34" charset="-122"/>
-                <a:cs typeface="Poppins" pitchFamily="34" charset="-120"/>
-              </a:rPr>
-              <a:t>, reducing costs, increasing efficiency, or solving other challenges.</a:t>
+              <a:t>Accurate to a third of a pixel on most pairs, honest about the rest, and fast enough to sit in an inspection loop on CPU alone.</a:t>
             </a:r>
             <a:endParaRPr lang="en-US" sz="1800" dirty="0"/>
           </a:p>
@@ -8480,7 +8391,7 @@
         </p:nvSpPr>
         <p:spPr>
           <a:xfrm>
-            <a:off x="1200607" y="4791456"/>
+            <a:off x="1200607" y="4658868"/>
             <a:ext cx="4148633" cy="1371600"/>
           </a:xfrm>
           <a:prstGeom prst="rect">
@@ -8503,13 +8414,13 @@
               <a:buNone/>
             </a:pPr>
             <a:r>
-              <a:rPr sz="1050">
+              <a:rPr sz="1050" dirty="0">
                 <a:solidFill>
                   <a:srgbClr val="D1D5DB"/>
                 </a:solidFill>
                 <a:latin typeface="Poppins"/>
               </a:rPr>
-              <a:t>The classical pipeline localizes to sub-pixel accuracy on most pairs (median error 0.33px). A validated 9x9 hypothesis-grid search recovers many rotation/scale-drift failures a coarser 5x5 grid misses, without regressing any unaffected case.</a:t>
+              <a:t>Median error is 0.32px — sub-pixel on most pairs. The system also knows when not to answer: it compares the winning match against its best rival more than 10px away, returns 64.7% of pairs at 95.0% accuracy, and defers the rest — catching 85.7% of all failures before they reach the tool.</a:t>
             </a:r>
             <a:endParaRPr lang="en-US" sz="1000" dirty="0"/>
           </a:p>
@@ -8621,7 +8532,7 @@
         </p:nvSpPr>
         <p:spPr>
           <a:xfrm>
-            <a:off x="6448349" y="4791456"/>
+            <a:off x="6448349" y="4738878"/>
             <a:ext cx="3986784" cy="1371600"/>
           </a:xfrm>
           <a:prstGeom prst="rect">
@@ -8644,13 +8555,13 @@
               <a:buNone/>
             </a:pPr>
             <a:r>
-              <a:rPr sz="1050">
+              <a:rPr sz="1050" dirty="0">
                 <a:solidFill>
                   <a:srgbClr val="D1D5DB"/>
                 </a:solidFill>
                 <a:latin typeface="Poppins"/>
               </a:rPr>
-              <a:t>71.2%@5px pooled (n=156). Mean error 65.3px → 53.6px. Candidate recall@5px 82.6% → 87.1%. Catastrophic (&gt;50px) rate 18.6% → 16.7%. ~1.6s/pair on CPU. Periodic-pattern catastrophic failures remain a known, disclosed limitation.</a:t>
+              <a:t>77.6%@5px pooled (n=156), up from 71.2% (+6.4pp). Identical at 4px and 2px; 72.4%@1px; 66.7% inside half a pixel. Median error 0.32px, mean 47.7px. Catastrophic (&gt;50px) 14.1%, down from 18.6%. 3.72s/pair on a single CPU core. Crops with no distinguishing macro structure remain the disclosed limitation.</a:t>
             </a:r>
             <a:endParaRPr lang="en-US" sz="1000" dirty="0"/>
           </a:p>
@@ -9334,8 +9245,8 @@
         </p:nvSpPr>
         <p:spPr>
           <a:xfrm>
-            <a:off x="1873494" y="3357677"/>
-            <a:ext cx="8748979" cy="1691640"/>
+            <a:off x="1873494" y="3445917"/>
+            <a:ext cx="8748979" cy="1700784"/>
           </a:xfrm>
           <a:prstGeom prst="rect">
             <a:avLst/>
@@ -9344,7 +9255,7 @@
           <a:ln/>
         </p:spPr>
         <p:txBody>
-          <a:bodyPr wrap="square" lIns="0" tIns="0" rIns="0" bIns="0" rtlCol="0" anchor="ctr"/>
+          <a:bodyPr wrap="square" lIns="0" tIns="0" rIns="0" bIns="0" rtlCol="0" anchor="t"/>
           <a:lstStyle/>
           <a:p>
             <a:pPr marL="0" indent="0" algn="l">
@@ -9363,7 +9274,7 @@
                 </a:solidFill>
                 <a:latin typeface="Poppins"/>
               </a:rPr>
-              <a:t>Feasibility: pure Python/OpenCV/NumPy classical pipeline, CPU-only in production (~1.6s/pair); </a:t>
+              <a:t>Feasibility: pure Python/OpenCV/NumPy classical pipeline, CPU-only in production (3.72s/pair, single core); </a:t>
             </a:r>
             <a:r>
               <a:rPr sz="1000" dirty="0" err="1">
@@ -9543,7 +9454,7 @@
                 </a:solidFill>
                 <a:latin typeface="Poppins"/>
               </a:rPr>
-              <a:t> (2008) Poisson-Gaussian noise modeling; Orji et al. (2018) Nature Electronics metrology; Applied Materials/Hugging Face SEM reference generator (official starter resource).</a:t>
+              <a:t> (2008) Poissonian-Gaussian noise; Orji et al. (2018) Nature Electronics metrology; Keeth et al. (2007) DRAM Circuit Design; Reimer (1998) SEM image formation. Full bibliography with DOIs: references/.</a:t>
             </a:r>
           </a:p>
           <a:p>
@@ -9562,7 +9473,7 @@
                 </a:solidFill>
                 <a:latin typeface="Poppins"/>
               </a:rPr>
-              <a:t>Future work: periodicity-aware re-ranking with more data, richer spatial context, robustness to unseen acquisition conditions.</a:t>
+              <a:t>Future work: residual failures are one-dimensional — error along a lattice axis, ~1.5px cross-axis. Open direction: escalating hypothesis density on flagged pairs (5 seeds, +2.8pp mean; not integrated — runtime and cross-seed stability fail the gate).</a:t>
             </a:r>
           </a:p>
         </p:txBody>
@@ -10813,7 +10724,7 @@
         <p:spPr>
           <a:xfrm>
             <a:off x="2848356" y="5239511"/>
-            <a:ext cx="7776362" cy="322783"/>
+            <a:ext cx="8321040" cy="322783"/>
           </a:xfrm>
           <a:prstGeom prst="rect">
             <a:avLst/>
@@ -10834,7 +10745,7 @@
               </a:spcAft>
             </a:pPr>
             <a:r>
-              <a:rPr lang="en-US" sz="1400" dirty="0">
+              <a:rPr lang="en-US" sz="1200" dirty="0">
                 <a:solidFill>
                   <a:srgbClr val="FFFFFF"/>
                 </a:solidFill>
@@ -11454,7 +11365,7 @@
         <p:spPr>
           <a:xfrm>
             <a:off x="1628546" y="2516429"/>
-            <a:ext cx="5701284" cy="191110"/>
+            <a:ext cx="9235440" cy="191110"/>
           </a:xfrm>
           <a:prstGeom prst="rect">
             <a:avLst/>
@@ -11478,7 +11389,7 @@
                 <a:ea typeface="Poppins" pitchFamily="34" charset="-122"/>
                 <a:cs typeface="Poppins" pitchFamily="34" charset="-120"/>
               </a:rPr>
-              <a:t>Briefly describe the research foundation or scientific principles supporting your idea.</a:t>
+              <a:t>Structures, imaging physics, noise and the matching method are each grounded in published sources, mapped to the code that implements them.</a:t>
             </a:r>
             <a:endParaRPr lang="en-US" sz="1000" dirty="0"/>
           </a:p>
@@ -11528,8 +11439,8 @@
         </p:nvSpPr>
         <p:spPr>
           <a:xfrm>
-            <a:off x="1790395" y="2945282"/>
-            <a:ext cx="5544007" cy="219456"/>
+            <a:off x="1790395" y="2884030"/>
+            <a:ext cx="9235440" cy="914400"/>
           </a:xfrm>
           <a:prstGeom prst="rect">
             <a:avLst/>
@@ -11545,7 +11456,7 @@
               <a:buNone/>
             </a:pPr>
             <a:r>
-              <a:rPr lang="en-US" sz="1200" i="1" dirty="0">
+              <a:rPr lang="en-US" sz="1050" i="1" dirty="0">
                 <a:solidFill>
                   <a:srgbClr val="FFFFFF">
                     <a:alpha val="70000"/>
@@ -11555,7 +11466,7 @@
                 <a:ea typeface="Poppins" pitchFamily="34" charset="-122"/>
                 <a:cs typeface="Poppins" pitchFamily="34" charset="-120"/>
               </a:rPr>
-              <a:t>{Detail your research findings, theoretical basis, or methodology here...}</a:t>
+              <a:t>Structures follow published DRAM array organisation: independently-rendered sub-array mats tiled with sense-amplifier and wordline-driver strips, so a wide field reads as blocks separated by peripheral bands rather than one continuous lattice. Acquisition is modelled as a chain — beam PSF and astigmatism, Poisson shot noise at a set dose, Gaussian read noise, charging, raster shear and jitter, radial scan nonlinearity — then exact 10× area-average decimation. Localization is normalised cross-correlation over 99 scale × rotation hypotheses.</a:t>
             </a:r>
             <a:endParaRPr lang="en-US" sz="1200" dirty="0"/>
           </a:p>
@@ -11666,7 +11577,7 @@
         <p:spPr>
           <a:xfrm>
             <a:off x="1628546" y="4497934"/>
-            <a:ext cx="2767889" cy="191110"/>
+            <a:ext cx="9235440" cy="191110"/>
           </a:xfrm>
           <a:prstGeom prst="rect">
             <a:avLst/>
@@ -11690,7 +11601,7 @@
                 <a:ea typeface="Poppins" pitchFamily="34" charset="-122"/>
                 <a:cs typeface="Poppins" pitchFamily="34" charset="-120"/>
               </a:rPr>
-              <a:t>List key papers, articles, or data sources.</a:t>
+              <a:t>Three load-bearing sources below; the full verified bibliography lives in references/.</a:t>
             </a:r>
             <a:endParaRPr lang="en-US" sz="1000" dirty="0"/>
           </a:p>
@@ -11770,7 +11681,7 @@
         <p:spPr>
           <a:xfrm>
             <a:off x="1790395" y="4926787"/>
-            <a:ext cx="3219602" cy="228600"/>
+            <a:ext cx="9235440" cy="274320"/>
           </a:xfrm>
           <a:prstGeom prst="rect">
             <a:avLst/>
@@ -11786,7 +11697,7 @@
               <a:buNone/>
             </a:pPr>
             <a:r>
-              <a:rPr lang="en-US" sz="1200" dirty="0">
+              <a:rPr lang="en-US" sz="1000" dirty="0">
                 <a:solidFill>
                   <a:srgbClr val="FFFFFF">
                     <a:alpha val="80000"/>
@@ -11796,7 +11707,7 @@
                 <a:ea typeface="Poppins" pitchFamily="34" charset="-122"/>
                 <a:cs typeface="Poppins" pitchFamily="34" charset="-120"/>
               </a:rPr>
-              <a:t>{Ref 1: Title of Paper/Article - Source/URL}</a:t>
+              <a:t>Keeth, Baker, Johnson &amp; Lin (2007). DRAM Circuit Design, 2nd ed. Wiley-IEEE Press. ISBN 978-0-470-18475-2 — mat / peripheral-strip array organisation.</a:t>
             </a:r>
             <a:endParaRPr lang="en-US" sz="1200" dirty="0"/>
           </a:p>
@@ -11840,7 +11751,7 @@
         <p:spPr>
           <a:xfrm>
             <a:off x="1790395" y="5355641"/>
-            <a:ext cx="3258007" cy="228600"/>
+            <a:ext cx="9235440" cy="274320"/>
           </a:xfrm>
           <a:prstGeom prst="rect">
             <a:avLst/>
@@ -11856,7 +11767,7 @@
               <a:buNone/>
             </a:pPr>
             <a:r>
-              <a:rPr lang="en-US" sz="1200" dirty="0">
+              <a:rPr lang="en-US" sz="1000" dirty="0">
                 <a:solidFill>
                   <a:srgbClr val="FFFFFF">
                     <a:alpha val="80000"/>
@@ -11866,7 +11777,7 @@
                 <a:ea typeface="Poppins" pitchFamily="34" charset="-122"/>
                 <a:cs typeface="Poppins" pitchFamily="34" charset="-120"/>
               </a:rPr>
-              <a:t>{Ref 2: Title of Paper/Article - Source/URL}</a:t>
+              <a:t>Reimer (1998). Scanning Electron Microscopy: Physics of Image Formation, 2nd ed. Springer. doi:10.1007/978-3-540-38967-5 — beam PSF, astigmatism.</a:t>
             </a:r>
             <a:endParaRPr lang="en-US" sz="1200" dirty="0"/>
           </a:p>
@@ -11881,7 +11792,7 @@
         <p:spPr>
           <a:xfrm>
             <a:off x="1790395" y="5783580"/>
-            <a:ext cx="3258007" cy="228600"/>
+            <a:ext cx="9235440" cy="274320"/>
           </a:xfrm>
           <a:prstGeom prst="rect">
             <a:avLst/>
@@ -11897,7 +11808,7 @@
               <a:buNone/>
             </a:pPr>
             <a:r>
-              <a:rPr lang="en-US" sz="1200" dirty="0">
+              <a:rPr lang="en-US" sz="1000" dirty="0">
                 <a:solidFill>
                   <a:srgbClr val="FFFFFF">
                     <a:alpha val="80000"/>
@@ -11907,7 +11818,7 @@
                 <a:ea typeface="Poppins" pitchFamily="34" charset="-122"/>
                 <a:cs typeface="Poppins" pitchFamily="34" charset="-120"/>
               </a:rPr>
-              <a:t>{Ref 3: Title of Paper/Article - Source/URL}</a:t>
+              <a:t>Foi, Trimeche, Katkovnik &amp; Egiazarian (2008). IEEE Trans. Image Processing 17(10). doi:10.1109/TIP.2008.2001399 — Poissonian-Gaussian shot + read noise.</a:t>
             </a:r>
             <a:endParaRPr lang="en-US" sz="1200" dirty="0"/>
           </a:p>

</xml_diff>